<commit_message>
build(assets): regenerar PDF+PPTX de las 232 clases + curso-completo (v3.10.0)
Regenera guia-explicativa.pdf y presentacion.pptx (+ mirrors docs/) de las 232
clases enriquecidas, mas curso-completo.pdf/.pptx y los 8 bundles por parte. Los
assets reflejan el tag de nivel y el contenido actualizado.

Co-Authored-By: Claude Opus 4.8 <noreply@anthropic.com>
</commit_message>
<xml_diff>
--- a/classes/parte-0-prerrequisitos/001-instalacion-de-python-3-12-y-entornos-virtuales-venv-uv-conda/clase-001-instalacion-de-python-3-12-y-entornos-virtuales-venv-uv-conda-presentacion.pptx
+++ b/classes/parte-0-prerrequisitos/001-instalacion-de-python-3-12-y-entornos-virtuales-venv-uv-conda/clase-001-instalacion-de-python-3-12-y-entornos-virtuales-venv-uv-conda-presentacion.pptx
@@ -3272,7 +3272,7 @@
                 </a:solidFill>
                 <a:latin typeface="Segoe UI"/>
               </a:rPr>
-              <a:t>Parte: 0 — Prerrequisitos · Fuente: VanderPlas, Python Data Science Handbook, prefacio "Installation Considerations". · Duración estimada: 90 min (45 lectura + 45 práctica).</a:t>
+              <a:t>Parte: 0 — Prerrequisitos · Fuente: VanderPlas, Python Data Science Handbook, prefacio "Installation Considerations". · Duración estimada: 90 min (45 lectura + 45 práctica). · Nivel: Básico</a:t>
             </a:r>
           </a:p>
         </p:txBody>
@@ -3581,7 +3581,7 @@
                 </a:solidFill>
                 <a:latin typeface="Segoe UI"/>
               </a:rPr>
-              <a:t>Parte: 0 — Prerrequisitos · Fuente: VanderPlas, Python Data Science Handbook, prefacio "Installation Considerations". · Duración estimada: 90 min (45 lectura + 45 práctica).</a:t>
+              <a:t>Parte: 0 — Prerrequisitos · Fuente: VanderPlas, Python Data Science Handbook, prefacio "Installation Considerations". · Duración estimada: 90 min (45 lectura + 45 práctica). · Nivel: Básico</a:t>
             </a:r>
           </a:p>
         </p:txBody>

</xml_diff>